<commit_message>
before restructure of order
</commit_message>
<xml_diff>
--- a/vignettes/figures/overview.pptx
+++ b/vignettes/figures/overview.pptx
@@ -131,9 +131,38 @@
 <file path=ppt/revisionInfo.xml><?xml version="1.0" encoding="utf-8"?>
 <p1510:revInfo xmlns:a="http://schemas.openxmlformats.org/drawingml/2006/main" xmlns:r="http://schemas.openxmlformats.org/officeDocument/2006/relationships" xmlns:p1510="http://schemas.microsoft.com/office/powerpoint/2015/10/main">
   <p1510:revLst>
-    <p1510:client id="{029578F4-396C-7740-87A7-C4D5F9DB13DB}" v="185" dt="2026-05-22T16:13:26.705"/>
+    <p1510:client id="{029578F4-396C-7740-87A7-C4D5F9DB13DB}" v="186" dt="2026-05-24T07:24:44.177"/>
   </p1510:revLst>
 </p1510:revInfo>
+</file>
+
+<file path=ppt/changesInfos/changesInfo1.xml><?xml version="1.0" encoding="utf-8"?>
+<pc:chgInfo xmlns:a="http://schemas.openxmlformats.org/drawingml/2006/main" xmlns:r="http://schemas.openxmlformats.org/officeDocument/2006/relationships" xmlns:ac="http://schemas.microsoft.com/office/drawing/2013/main/command" xmlns:pc="http://schemas.microsoft.com/office/powerpoint/2013/main/command">
+  <pc:docChgLst>
+    <pc:chgData name="Schilling Sabine HSLU W" userId="b0e2af5c-9187-4900-883a-c96514cd8e15" providerId="ADAL" clId="{5E51067F-94D7-505D-9735-0698788361AC}"/>
+    <pc:docChg chg="custSel modSld">
+      <pc:chgData name="Schilling Sabine HSLU W" userId="b0e2af5c-9187-4900-883a-c96514cd8e15" providerId="ADAL" clId="{5E51067F-94D7-505D-9735-0698788361AC}" dt="2026-05-24T07:24:55.295" v="3" actId="478"/>
+      <pc:docMkLst>
+        <pc:docMk/>
+      </pc:docMkLst>
+      <pc:sldChg chg="addSp delSp modSp mod">
+        <pc:chgData name="Schilling Sabine HSLU W" userId="b0e2af5c-9187-4900-883a-c96514cd8e15" providerId="ADAL" clId="{5E51067F-94D7-505D-9735-0698788361AC}" dt="2026-05-24T07:24:55.295" v="3" actId="478"/>
+        <pc:sldMkLst>
+          <pc:docMk/>
+          <pc:sldMk cId="2052569025" sldId="275"/>
+        </pc:sldMkLst>
+        <pc:spChg chg="add del mod">
+          <ac:chgData name="Schilling Sabine HSLU W" userId="b0e2af5c-9187-4900-883a-c96514cd8e15" providerId="ADAL" clId="{5E51067F-94D7-505D-9735-0698788361AC}" dt="2026-05-24T07:24:55.295" v="3" actId="478"/>
+          <ac:spMkLst>
+            <pc:docMk/>
+            <pc:sldMk cId="2052569025" sldId="275"/>
+            <ac:spMk id="2" creationId="{5221C6E7-7004-E29B-D134-11E560A04FAD}"/>
+          </ac:spMkLst>
+        </pc:spChg>
+      </pc:sldChg>
+    </pc:docChg>
+  </pc:docChgLst>
+</pc:chgInfo>
 </file>
 
 <file path=ppt/notesMasters/notesMaster1.xml><?xml version="1.0" encoding="utf-8"?>
@@ -218,7 +247,7 @@
           <a:p>
             <a:fld id="{0AECA108-3915-9043-8428-B4BE4472B821}" type="datetimeFigureOut">
               <a:rPr lang="de-DE" smtClean="0"/>
-              <a:t>18.05.26</a:t>
+              <a:t>24.05.26</a:t>
             </a:fld>
             <a:endParaRPr lang="de-DE"/>
           </a:p>
@@ -1016,7 +1045,7 @@
           <a:p>
             <a:fld id="{43497422-92ED-3D47-BF28-17000E80E497}" type="datetimeFigureOut">
               <a:rPr lang="de-DE" smtClean="0"/>
-              <a:t>18.05.26</a:t>
+              <a:t>24.05.26</a:t>
             </a:fld>
             <a:endParaRPr lang="de-DE"/>
           </a:p>
@@ -1214,7 +1243,7 @@
           <a:p>
             <a:fld id="{43497422-92ED-3D47-BF28-17000E80E497}" type="datetimeFigureOut">
               <a:rPr lang="de-DE" smtClean="0"/>
-              <a:t>18.05.26</a:t>
+              <a:t>24.05.26</a:t>
             </a:fld>
             <a:endParaRPr lang="de-DE"/>
           </a:p>
@@ -1422,7 +1451,7 @@
           <a:p>
             <a:fld id="{43497422-92ED-3D47-BF28-17000E80E497}" type="datetimeFigureOut">
               <a:rPr lang="de-DE" smtClean="0"/>
-              <a:t>18.05.26</a:t>
+              <a:t>24.05.26</a:t>
             </a:fld>
             <a:endParaRPr lang="de-DE"/>
           </a:p>
@@ -1620,7 +1649,7 @@
           <a:p>
             <a:fld id="{43497422-92ED-3D47-BF28-17000E80E497}" type="datetimeFigureOut">
               <a:rPr lang="de-DE" smtClean="0"/>
-              <a:t>18.05.26</a:t>
+              <a:t>24.05.26</a:t>
             </a:fld>
             <a:endParaRPr lang="de-DE"/>
           </a:p>
@@ -1895,7 +1924,7 @@
           <a:p>
             <a:fld id="{43497422-92ED-3D47-BF28-17000E80E497}" type="datetimeFigureOut">
               <a:rPr lang="de-DE" smtClean="0"/>
-              <a:t>18.05.26</a:t>
+              <a:t>24.05.26</a:t>
             </a:fld>
             <a:endParaRPr lang="de-DE"/>
           </a:p>
@@ -2160,7 +2189,7 @@
           <a:p>
             <a:fld id="{43497422-92ED-3D47-BF28-17000E80E497}" type="datetimeFigureOut">
               <a:rPr lang="de-DE" smtClean="0"/>
-              <a:t>18.05.26</a:t>
+              <a:t>24.05.26</a:t>
             </a:fld>
             <a:endParaRPr lang="de-DE"/>
           </a:p>
@@ -2572,7 +2601,7 @@
           <a:p>
             <a:fld id="{43497422-92ED-3D47-BF28-17000E80E497}" type="datetimeFigureOut">
               <a:rPr lang="de-DE" smtClean="0"/>
-              <a:t>18.05.26</a:t>
+              <a:t>24.05.26</a:t>
             </a:fld>
             <a:endParaRPr lang="de-DE"/>
           </a:p>
@@ -2713,7 +2742,7 @@
           <a:p>
             <a:fld id="{43497422-92ED-3D47-BF28-17000E80E497}" type="datetimeFigureOut">
               <a:rPr lang="de-DE" smtClean="0"/>
-              <a:t>18.05.26</a:t>
+              <a:t>24.05.26</a:t>
             </a:fld>
             <a:endParaRPr lang="de-DE"/>
           </a:p>
@@ -2826,7 +2855,7 @@
           <a:p>
             <a:fld id="{43497422-92ED-3D47-BF28-17000E80E497}" type="datetimeFigureOut">
               <a:rPr lang="de-DE" smtClean="0"/>
-              <a:t>18.05.26</a:t>
+              <a:t>24.05.26</a:t>
             </a:fld>
             <a:endParaRPr lang="de-DE"/>
           </a:p>
@@ -3137,7 +3166,7 @@
           <a:p>
             <a:fld id="{43497422-92ED-3D47-BF28-17000E80E497}" type="datetimeFigureOut">
               <a:rPr lang="de-DE" smtClean="0"/>
-              <a:t>18.05.26</a:t>
+              <a:t>24.05.26</a:t>
             </a:fld>
             <a:endParaRPr lang="de-DE"/>
           </a:p>
@@ -3425,7 +3454,7 @@
           <a:p>
             <a:fld id="{43497422-92ED-3D47-BF28-17000E80E497}" type="datetimeFigureOut">
               <a:rPr lang="de-DE" smtClean="0"/>
-              <a:t>18.05.26</a:t>
+              <a:t>24.05.26</a:t>
             </a:fld>
             <a:endParaRPr lang="de-DE"/>
           </a:p>
@@ -3666,7 +3695,7 @@
           <a:p>
             <a:fld id="{43497422-92ED-3D47-BF28-17000E80E497}" type="datetimeFigureOut">
               <a:rPr lang="de-DE" smtClean="0"/>
-              <a:t>18.05.26</a:t>
+              <a:t>24.05.26</a:t>
             </a:fld>
             <a:endParaRPr lang="de-DE"/>
           </a:p>
@@ -4888,8 +4917,8 @@
             </p:sp>
           </mc:Fallback>
         </mc:AlternateContent>
-        <mc:AlternateContent xmlns:mc="http://schemas.openxmlformats.org/markup-compatibility/2006">
-          <mc:Choice xmlns:a14="http://schemas.microsoft.com/office/drawing/2010/main" Requires="a14">
+        <mc:AlternateContent xmlns:mc="http://schemas.openxmlformats.org/markup-compatibility/2006" xmlns:a14="http://schemas.microsoft.com/office/drawing/2010/main">
+          <mc:Choice Requires="a14">
             <p:sp>
               <p:nvSpPr>
                 <p:cNvPr id="7" name="Textfeld 6">
@@ -5103,7 +5132,7 @@
               </p:txBody>
             </p:sp>
           </mc:Choice>
-          <mc:Fallback>
+          <mc:Fallback xmlns="">
             <p:sp>
               <p:nvSpPr>
                 <p:cNvPr id="7" name="Textfeld 6">
@@ -5642,8 +5671,8 @@
             </p:sp>
           </mc:Fallback>
         </mc:AlternateContent>
-        <mc:AlternateContent xmlns:mc="http://schemas.openxmlformats.org/markup-compatibility/2006">
-          <mc:Choice xmlns:a14="http://schemas.microsoft.com/office/drawing/2010/main" Requires="a14">
+        <mc:AlternateContent xmlns:mc="http://schemas.openxmlformats.org/markup-compatibility/2006" xmlns:a14="http://schemas.microsoft.com/office/drawing/2010/main">
+          <mc:Choice Requires="a14">
             <p:sp>
               <p:nvSpPr>
                 <p:cNvPr id="5" name="Textfeld 4">
@@ -5834,7 +5863,7 @@
               </p:txBody>
             </p:sp>
           </mc:Choice>
-          <mc:Fallback>
+          <mc:Fallback xmlns="">
             <p:sp>
               <p:nvSpPr>
                 <p:cNvPr id="5" name="Textfeld 4">
@@ -7107,8 +7136,8 @@
               </a:p>
             </p:txBody>
           </p:sp>
-          <mc:AlternateContent xmlns:mc="http://schemas.openxmlformats.org/markup-compatibility/2006">
-            <mc:Choice xmlns:a14="http://schemas.microsoft.com/office/drawing/2010/main" Requires="a14">
+          <mc:AlternateContent xmlns:mc="http://schemas.openxmlformats.org/markup-compatibility/2006" xmlns:a14="http://schemas.microsoft.com/office/drawing/2010/main">
+            <mc:Choice Requires="a14">
               <p:sp>
                 <p:nvSpPr>
                   <p:cNvPr id="7" name="Textfeld 6">
@@ -7304,7 +7333,7 @@
                 </p:txBody>
               </p:sp>
             </mc:Choice>
-            <mc:Fallback>
+            <mc:Fallback xmlns="">
               <p:sp>
                 <p:nvSpPr>
                   <p:cNvPr id="7" name="Textfeld 6">
@@ -7589,8 +7618,8 @@
               </a:p>
             </p:txBody>
           </p:sp>
-          <mc:AlternateContent xmlns:mc="http://schemas.openxmlformats.org/markup-compatibility/2006">
-            <mc:Choice xmlns:a14="http://schemas.microsoft.com/office/drawing/2010/main" Requires="a14">
+          <mc:AlternateContent xmlns:mc="http://schemas.openxmlformats.org/markup-compatibility/2006" xmlns:a14="http://schemas.microsoft.com/office/drawing/2010/main">
+            <mc:Choice Requires="a14">
               <p:sp>
                 <p:nvSpPr>
                   <p:cNvPr id="5" name="Textfeld 4">
@@ -7781,7 +7810,7 @@
                 </p:txBody>
               </p:sp>
             </mc:Choice>
-            <mc:Fallback>
+            <mc:Fallback xmlns="">
               <p:sp>
                 <p:nvSpPr>
                   <p:cNvPr id="5" name="Textfeld 4">
@@ -7964,8 +7993,8 @@
               </a:fontRef>
             </p:style>
           </p:cxnSp>
-          <mc:AlternateContent xmlns:mc="http://schemas.openxmlformats.org/markup-compatibility/2006">
-            <mc:Choice xmlns:a14="http://schemas.microsoft.com/office/drawing/2010/main" Requires="a14">
+          <mc:AlternateContent xmlns:mc="http://schemas.openxmlformats.org/markup-compatibility/2006" xmlns:a14="http://schemas.microsoft.com/office/drawing/2010/main">
+            <mc:Choice Requires="a14">
               <p:sp>
                 <p:nvSpPr>
                   <p:cNvPr id="11" name="Textfeld 10">
@@ -8198,7 +8227,7 @@
                 </p:txBody>
               </p:sp>
             </mc:Choice>
-            <mc:Fallback>
+            <mc:Fallback xmlns="">
               <p:sp>
                 <p:nvSpPr>
                   <p:cNvPr id="11" name="Textfeld 10">
@@ -9277,8 +9306,8 @@
             </a:p>
           </p:txBody>
         </p:sp>
-        <mc:AlternateContent xmlns:mc="http://schemas.openxmlformats.org/markup-compatibility/2006">
-          <mc:Choice xmlns:a14="http://schemas.microsoft.com/office/drawing/2010/main" Requires="a14">
+        <mc:AlternateContent xmlns:mc="http://schemas.openxmlformats.org/markup-compatibility/2006" xmlns:a14="http://schemas.microsoft.com/office/drawing/2010/main">
+          <mc:Choice Requires="a14">
             <p:sp>
               <p:nvSpPr>
                 <p:cNvPr id="6" name="Textfeld 5">
@@ -9642,7 +9671,7 @@
               </p:txBody>
             </p:sp>
           </mc:Choice>
-          <mc:Fallback>
+          <mc:Fallback xmlns="">
             <p:sp>
               <p:nvSpPr>
                 <p:cNvPr id="6" name="Textfeld 5">
@@ -10107,8 +10136,8 @@
             </a:p>
           </p:txBody>
         </p:sp>
-        <mc:AlternateContent xmlns:mc="http://schemas.openxmlformats.org/markup-compatibility/2006">
-          <mc:Choice xmlns:a14="http://schemas.microsoft.com/office/drawing/2010/main" Requires="a14">
+        <mc:AlternateContent xmlns:mc="http://schemas.openxmlformats.org/markup-compatibility/2006" xmlns:a14="http://schemas.microsoft.com/office/drawing/2010/main">
+          <mc:Choice Requires="a14">
             <p:sp>
               <p:nvSpPr>
                 <p:cNvPr id="9" name="Textfeld 8">
@@ -10420,7 +10449,7 @@
               </p:txBody>
             </p:sp>
           </mc:Choice>
-          <mc:Fallback>
+          <mc:Fallback xmlns="">
             <p:sp>
               <p:nvSpPr>
                 <p:cNvPr id="9" name="Textfeld 8">
@@ -10611,8 +10640,8 @@
             </a:p>
           </p:txBody>
         </p:sp>
-        <mc:AlternateContent xmlns:mc="http://schemas.openxmlformats.org/markup-compatibility/2006">
-          <mc:Choice xmlns:a14="http://schemas.microsoft.com/office/drawing/2010/main" Requires="a14">
+        <mc:AlternateContent xmlns:mc="http://schemas.openxmlformats.org/markup-compatibility/2006" xmlns:a14="http://schemas.microsoft.com/office/drawing/2010/main">
+          <mc:Choice Requires="a14">
             <p:sp>
               <p:nvSpPr>
                 <p:cNvPr id="7" name="Textfeld 6">
@@ -10966,7 +10995,7 @@
               </p:txBody>
             </p:sp>
           </mc:Choice>
-          <mc:Fallback>
+          <mc:Fallback xmlns="">
             <p:sp>
               <p:nvSpPr>
                 <p:cNvPr id="7" name="Textfeld 6">
@@ -11429,8 +11458,8 @@
             </a:p>
           </p:txBody>
         </p:sp>
-        <mc:AlternateContent xmlns:mc="http://schemas.openxmlformats.org/markup-compatibility/2006">
-          <mc:Choice xmlns:a14="http://schemas.microsoft.com/office/drawing/2010/main" Requires="a14">
+        <mc:AlternateContent xmlns:mc="http://schemas.openxmlformats.org/markup-compatibility/2006" xmlns:a14="http://schemas.microsoft.com/office/drawing/2010/main">
+          <mc:Choice Requires="a14">
             <p:sp>
               <p:nvSpPr>
                 <p:cNvPr id="5" name="Textfeld 4">
@@ -11822,7 +11851,7 @@
               </p:txBody>
             </p:sp>
           </mc:Choice>
-          <mc:Fallback>
+          <mc:Fallback xmlns="">
             <p:sp>
               <p:nvSpPr>
                 <p:cNvPr id="5" name="Textfeld 4">
@@ -12005,8 +12034,8 @@
             </a:fontRef>
           </p:style>
         </p:cxnSp>
-        <mc:AlternateContent xmlns:mc="http://schemas.openxmlformats.org/markup-compatibility/2006">
-          <mc:Choice xmlns:a14="http://schemas.microsoft.com/office/drawing/2010/main" Requires="a14">
+        <mc:AlternateContent xmlns:mc="http://schemas.openxmlformats.org/markup-compatibility/2006" xmlns:a14="http://schemas.microsoft.com/office/drawing/2010/main">
+          <mc:Choice Requires="a14">
             <p:sp>
               <p:nvSpPr>
                 <p:cNvPr id="11" name="Textfeld 10">
@@ -12429,7 +12458,7 @@
               </p:txBody>
             </p:sp>
           </mc:Choice>
-          <mc:Fallback>
+          <mc:Fallback xmlns="">
             <p:sp>
               <p:nvSpPr>
                 <p:cNvPr id="11" name="Textfeld 10">

</xml_diff>